<commit_message>
Revise OOAD sessions and presentation production
</commit_message>
<xml_diff>
--- a/courses/ooad/sessions/references.pptx
+++ b/courses/ooad/sessions/references.pptx
@@ -2361,7 +2361,7 @@
                 <a:latin typeface="맑은 고딕"/>
                 <a:ea typeface="맑은 고딕"/>
               </a:rPr>
-              <a:t>  Object-Oriented Analysis and Design with Applications, 2nd ed., Grady Booch, Benjamin/Cummings, 1994</a:t>
+              <a:t>  Object-Oriented Analysis and Design with Applications, 2nd ed., Grady Booch, 1994</a:t>
             </a:r>
           </a:p>
           <a:p>
@@ -2627,7 +2627,7 @@
                 <a:latin typeface="맑은 고딕"/>
                 <a:ea typeface="맑은 고딕"/>
               </a:rPr>
-              <a:t>  Behaviour-Driven Development, Cucumber documentation, https://cucumber.io/docs/bdd/</a:t>
+              <a:t>  Behaviour-Driven Development, Cucumber documentation</a:t>
             </a:r>
           </a:p>
           <a:p>
@@ -2912,17 +2912,17 @@
                 <a:latin typeface="맑은 고딕"/>
                 <a:ea typeface="맑은 고딕"/>
               </a:rPr>
-              <a:t>[Fowler 2003a]</a:t>
-            </a:r>
-            <a:r>
-              <a:rPr sz="800" b="0">
-                <a:solidFill>
-                  <a:srgbClr val="000000"/>
-                </a:solidFill>
-                <a:latin typeface="맑은 고딕"/>
-                <a:ea typeface="맑은 고딕"/>
-              </a:rPr>
-              <a:t>  AggregationAndComposition, Martin Fowler, martinfowler.com, 2003, https://martinfowler.com/bliki/AggregationAndComposition.html</a:t>
+              <a:t>[Fowler 2003b]</a:t>
+            </a:r>
+            <a:r>
+              <a:rPr sz="800" b="0">
+                <a:solidFill>
+                  <a:srgbClr val="000000"/>
+                </a:solidFill>
+                <a:latin typeface="맑은 고딕"/>
+                <a:ea typeface="맑은 고딕"/>
+              </a:rPr>
+              <a:t>  AnemicDomainModel, Martin Fowler, martinfowler.com, 2003, https://martinfowler.com/bliki/AnemicDomainModel.html</a:t>
             </a:r>
           </a:p>
           <a:p>
@@ -2953,17 +2953,37 @@
                 <a:latin typeface="맑은 고딕"/>
                 <a:ea typeface="맑은 고딕"/>
               </a:rPr>
-              <a:t>[Fowler 2003b]</a:t>
-            </a:r>
-            <a:r>
-              <a:rPr sz="800" b="0">
-                <a:solidFill>
-                  <a:srgbClr val="000000"/>
-                </a:solidFill>
-                <a:latin typeface="맑은 고딕"/>
-                <a:ea typeface="맑은 고딕"/>
-              </a:rPr>
-              <a:t>  AnemicDomainModel, Martin Fowler, martinfowler.com, 2003, https://martinfowler.com/bliki/AnemicDomainModel.html</a:t>
+              <a:t>[Fowler 2003c]</a:t>
+            </a:r>
+            <a:r>
+              <a:rPr sz="800" b="0">
+                <a:solidFill>
+                  <a:srgbClr val="000000"/>
+                </a:solidFill>
+                <a:latin typeface="맑은 고딕"/>
+                <a:ea typeface="맑은 고딕"/>
+              </a:rPr>
+              <a:t>  Who Needs an Architect?, Martin Fowler, IEEE Software 20</a:t>
+            </a:r>
+            <a:r>
+              <a:rPr sz="800" b="0">
+                <a:solidFill>
+                  <a:srgbClr val="000000"/>
+                </a:solidFill>
+                <a:latin typeface="맑은 고딕"/>
+                <a:ea typeface="맑은 고딕"/>
+              </a:rPr>
+              <a:t>(5)</a:t>
+            </a:r>
+            <a:r>
+              <a:rPr sz="800" b="0">
+                <a:solidFill>
+                  <a:srgbClr val="000000"/>
+                </a:solidFill>
+                <a:latin typeface="맑은 고딕"/>
+                <a:ea typeface="맑은 고딕"/>
+              </a:rPr>
+              <a:t>, 2003</a:t>
             </a:r>
           </a:p>
           <a:p>
@@ -2994,37 +3014,17 @@
                 <a:latin typeface="맑은 고딕"/>
                 <a:ea typeface="맑은 고딕"/>
               </a:rPr>
-              <a:t>[Fowler 2003c]</a:t>
-            </a:r>
-            <a:r>
-              <a:rPr sz="800" b="0">
-                <a:solidFill>
-                  <a:srgbClr val="000000"/>
-                </a:solidFill>
-                <a:latin typeface="맑은 고딕"/>
-                <a:ea typeface="맑은 고딕"/>
-              </a:rPr>
-              <a:t>  Who Needs an Architect?, Martin Fowler, IEEE Software 20</a:t>
-            </a:r>
-            <a:r>
-              <a:rPr sz="800" b="0">
-                <a:solidFill>
-                  <a:srgbClr val="000000"/>
-                </a:solidFill>
-                <a:latin typeface="맑은 고딕"/>
-                <a:ea typeface="맑은 고딕"/>
-              </a:rPr>
-              <a:t>(5)</a:t>
-            </a:r>
-            <a:r>
-              <a:rPr sz="800" b="0">
-                <a:solidFill>
-                  <a:srgbClr val="000000"/>
-                </a:solidFill>
-                <a:latin typeface="맑은 고딕"/>
-                <a:ea typeface="맑은 고딕"/>
-              </a:rPr>
-              <a:t>, 2003</a:t>
+              <a:t>[Fowler 2004]</a:t>
+            </a:r>
+            <a:r>
+              <a:rPr sz="800" b="0">
+                <a:solidFill>
+                  <a:srgbClr val="000000"/>
+                </a:solidFill>
+                <a:latin typeface="맑은 고딕"/>
+                <a:ea typeface="맑은 고딕"/>
+              </a:rPr>
+              <a:t>  UML Distilled, 3rd ed., Martin Fowler, Addison-Wesley, 2004</a:t>
             </a:r>
           </a:p>
           <a:p>
@@ -3055,17 +3055,17 @@
                 <a:latin typeface="맑은 고딕"/>
                 <a:ea typeface="맑은 고딕"/>
               </a:rPr>
-              <a:t>[Fowler 2004]</a:t>
-            </a:r>
-            <a:r>
-              <a:rPr sz="800" b="0">
-                <a:solidFill>
-                  <a:srgbClr val="000000"/>
-                </a:solidFill>
-                <a:latin typeface="맑은 고딕"/>
-                <a:ea typeface="맑은 고딕"/>
-              </a:rPr>
-              <a:t>  UML Distilled, 3rd ed., Martin Fowler, Addison-Wesley, 2004</a:t>
+              <a:t>[Fowler 2011]</a:t>
+            </a:r>
+            <a:r>
+              <a:rPr sz="800" b="0">
+                <a:solidFill>
+                  <a:srgbClr val="000000"/>
+                </a:solidFill>
+                <a:latin typeface="맑은 고딕"/>
+                <a:ea typeface="맑은 고딕"/>
+              </a:rPr>
+              <a:t>  FrequencyReducesDifficulty, Martin Fowler, martinfowler.com, 2011, https://martinfowler.com/bliki/FrequencyReducesDifficulty.html</a:t>
             </a:r>
           </a:p>
           <a:p>
@@ -3096,17 +3096,17 @@
                 <a:latin typeface="맑은 고딕"/>
                 <a:ea typeface="맑은 고딕"/>
               </a:rPr>
-              <a:t>[Fowler 2011]</a:t>
-            </a:r>
-            <a:r>
-              <a:rPr sz="800" b="0">
-                <a:solidFill>
-                  <a:srgbClr val="000000"/>
-                </a:solidFill>
-                <a:latin typeface="맑은 고딕"/>
-                <a:ea typeface="맑은 고딕"/>
-              </a:rPr>
-              <a:t>  FrequencyReducesDifficulty, Martin Fowler, martinfowler.com, 2011, https://martinfowler.com/bliki/FrequencyReducesDifficulty.html</a:t>
+              <a:t>[Fowler 2014]</a:t>
+            </a:r>
+            <a:r>
+              <a:rPr sz="800" b="0">
+                <a:solidFill>
+                  <a:srgbClr val="000000"/>
+                </a:solidFill>
+                <a:latin typeface="맑은 고딕"/>
+                <a:ea typeface="맑은 고딕"/>
+              </a:rPr>
+              <a:t>  Microservices and the First Law of Distributed Objects, Martin Fowler, martinfowler.com, 2014, https://martinfowler.com/articles/distributed-objects-microservices.html</a:t>
             </a:r>
           </a:p>
           <a:p>
@@ -3137,17 +3137,17 @@
                 <a:latin typeface="맑은 고딕"/>
                 <a:ea typeface="맑은 고딕"/>
               </a:rPr>
-              <a:t>[Fowler 2014]</a:t>
-            </a:r>
-            <a:r>
-              <a:rPr sz="800" b="0">
-                <a:solidFill>
-                  <a:srgbClr val="000000"/>
-                </a:solidFill>
-                <a:latin typeface="맑은 고딕"/>
-                <a:ea typeface="맑은 고딕"/>
-              </a:rPr>
-              <a:t>  Microservices and the First Law of Distributed Objects, Martin Fowler, martinfowler.com, 2014, https://martinfowler.com/articles/distributed-objects-microservices.html</a:t>
+              <a:t>[Fowler 2015a]</a:t>
+            </a:r>
+            <a:r>
+              <a:rPr sz="800" b="0">
+                <a:solidFill>
+                  <a:srgbClr val="000000"/>
+                </a:solidFill>
+                <a:latin typeface="맑은 고딕"/>
+                <a:ea typeface="맑은 고딕"/>
+              </a:rPr>
+              <a:t>  Yagni, Martin Fowler, martinfowler.com, 2015, https://martinfowler.com/bliki/Yagni.html</a:t>
             </a:r>
           </a:p>
           <a:p>
@@ -3178,17 +3178,17 @@
                 <a:latin typeface="맑은 고딕"/>
                 <a:ea typeface="맑은 고딕"/>
               </a:rPr>
-              <a:t>[Fowler 2015a]</a:t>
-            </a:r>
-            <a:r>
-              <a:rPr sz="800" b="0">
-                <a:solidFill>
-                  <a:srgbClr val="000000"/>
-                </a:solidFill>
-                <a:latin typeface="맑은 고딕"/>
-                <a:ea typeface="맑은 고딕"/>
-              </a:rPr>
-              <a:t>  Yagni, Martin Fowler, martinfowler.com, 2015, https://martinfowler.com/bliki/Yagni.html</a:t>
+              <a:t>[Fowler 2015b]</a:t>
+            </a:r>
+            <a:r>
+              <a:rPr sz="800" b="0">
+                <a:solidFill>
+                  <a:srgbClr val="000000"/>
+                </a:solidFill>
+                <a:latin typeface="맑은 고딕"/>
+                <a:ea typeface="맑은 고딕"/>
+              </a:rPr>
+              <a:t>  BeckDesignRules, Martin Fowler, martinfowler.com, 2015, https://martinfowler.com/bliki/BeckDesignRules.html</a:t>
             </a:r>
           </a:p>
           <a:p>
@@ -3219,17 +3219,17 @@
                 <a:latin typeface="맑은 고딕"/>
                 <a:ea typeface="맑은 고딕"/>
               </a:rPr>
-              <a:t>[Fowler 2015b]</a:t>
-            </a:r>
-            <a:r>
-              <a:rPr sz="800" b="0">
-                <a:solidFill>
-                  <a:srgbClr val="000000"/>
-                </a:solidFill>
-                <a:latin typeface="맑은 고딕"/>
-                <a:ea typeface="맑은 고딕"/>
-              </a:rPr>
-              <a:t>  BeckDesignRules, Martin Fowler, martinfowler.com, 2015, https://martinfowler.com/bliki/BeckDesignRules.html</a:t>
+              <a:t>[Fowler 2015c]</a:t>
+            </a:r>
+            <a:r>
+              <a:rPr sz="800" b="0">
+                <a:solidFill>
+                  <a:srgbClr val="000000"/>
+                </a:solidFill>
+                <a:latin typeface="맑은 고딕"/>
+                <a:ea typeface="맑은 고딕"/>
+              </a:rPr>
+              <a:t>  MonolithFirst, Martin Fowler, martinfowler.com, 2015, https://martinfowler.com/bliki/MonolithFirst.html</a:t>
             </a:r>
           </a:p>
           <a:p>
@@ -3260,17 +3260,17 @@
                 <a:latin typeface="맑은 고딕"/>
                 <a:ea typeface="맑은 고딕"/>
               </a:rPr>
-              <a:t>[Fowler 2015c]</a:t>
-            </a:r>
-            <a:r>
-              <a:rPr sz="800" b="0">
-                <a:solidFill>
-                  <a:srgbClr val="000000"/>
-                </a:solidFill>
-                <a:latin typeface="맑은 고딕"/>
-                <a:ea typeface="맑은 고딕"/>
-              </a:rPr>
-              <a:t>  MonolithFirst, Martin Fowler, martinfowler.com, 2015, https://martinfowler.com/bliki/MonolithFirst.html</a:t>
+              <a:t>[Fowler 2015d]</a:t>
+            </a:r>
+            <a:r>
+              <a:rPr sz="800" b="0">
+                <a:solidFill>
+                  <a:srgbClr val="000000"/>
+                </a:solidFill>
+                <a:latin typeface="맑은 고딕"/>
+                <a:ea typeface="맑은 고딕"/>
+              </a:rPr>
+              <a:t>  MicroservicePremium, Martin Fowler, martinfowler.com, 2015, https://martinfowler.com/bliki/MicroservicePremium.html</a:t>
             </a:r>
           </a:p>
           <a:p>
@@ -3301,17 +3301,17 @@
                 <a:latin typeface="맑은 고딕"/>
                 <a:ea typeface="맑은 고딕"/>
               </a:rPr>
-              <a:t>[Fowler 2015d]</a:t>
-            </a:r>
-            <a:r>
-              <a:rPr sz="800" b="0">
-                <a:solidFill>
-                  <a:srgbClr val="000000"/>
-                </a:solidFill>
-                <a:latin typeface="맑은 고딕"/>
-                <a:ea typeface="맑은 고딕"/>
-              </a:rPr>
-              <a:t>  MicroservicePremium, Martin Fowler, martinfowler.com, 2015, https://martinfowler.com/bliki/MicroservicePremium.html</a:t>
+              <a:t>[Fowler 2024]</a:t>
+            </a:r>
+            <a:r>
+              <a:rPr sz="800" b="0">
+                <a:solidFill>
+                  <a:srgbClr val="000000"/>
+                </a:solidFill>
+                <a:latin typeface="맑은 고딕"/>
+                <a:ea typeface="맑은 고딕"/>
+              </a:rPr>
+              <a:t>  Continuous Integration, Martin Fowler, martinfowler.com, 2024, https://martinfowler.com/articles/continuousIntegration.html</a:t>
             </a:r>
           </a:p>
           <a:p>
@@ -3342,17 +3342,17 @@
                 <a:latin typeface="맑은 고딕"/>
                 <a:ea typeface="맑은 고딕"/>
               </a:rPr>
-              <a:t>[Fowler 2024]</a:t>
-            </a:r>
-            <a:r>
-              <a:rPr sz="800" b="0">
-                <a:solidFill>
-                  <a:srgbClr val="000000"/>
-                </a:solidFill>
-                <a:latin typeface="맑은 고딕"/>
-                <a:ea typeface="맑은 고딕"/>
-              </a:rPr>
-              <a:t>  Continuous Integration, Martin Fowler, martinfowler.com, 2024, https://martinfowler.com/articles/continuousIntegration.html</a:t>
+              <a:t>[Gamma 외 1994]</a:t>
+            </a:r>
+            <a:r>
+              <a:rPr sz="800" b="0">
+                <a:solidFill>
+                  <a:srgbClr val="000000"/>
+                </a:solidFill>
+                <a:latin typeface="맑은 고딕"/>
+                <a:ea typeface="맑은 고딕"/>
+              </a:rPr>
+              <a:t>  Design Patterns: Elements of Reusable Object-Oriented Software, Erich Gamma·Richard Helm·Ralph Johnson·John Vlissides, Addison-Wesley, 1994</a:t>
             </a:r>
           </a:p>
           <a:p>
@@ -3383,17 +3383,27 @@
                 <a:latin typeface="맑은 고딕"/>
                 <a:ea typeface="맑은 고딕"/>
               </a:rPr>
-              <a:t>[Gamma 외 1994]</a:t>
-            </a:r>
-            <a:r>
-              <a:rPr sz="800" b="0">
-                <a:solidFill>
-                  <a:srgbClr val="000000"/>
-                </a:solidFill>
-                <a:latin typeface="맑은 고딕"/>
-                <a:ea typeface="맑은 고딕"/>
-              </a:rPr>
-              <a:t>  Design Patterns: Elements of Reusable Object-Oriented Software, Erich Gamma·Richard Helm·Ralph Johnson·John Vlissides, Addison-Wesley, 1994</a:t>
+              <a:t>[Gamma 2005]</a:t>
+            </a:r>
+            <a:r>
+              <a:rPr sz="800" b="0">
+                <a:solidFill>
+                  <a:srgbClr val="000000"/>
+                </a:solidFill>
+                <a:latin typeface="맑은 고딕"/>
+                <a:ea typeface="맑은 고딕"/>
+              </a:rPr>
+              <a:t>  Design Principles from Design Patterns —</a:t>
+            </a:r>
+            <a:r>
+              <a:rPr sz="800" b="0">
+                <a:solidFill>
+                  <a:srgbClr val="000000"/>
+                </a:solidFill>
+                <a:latin typeface="맑은 고딕"/>
+                <a:ea typeface="맑은 고딕"/>
+              </a:rPr>
+              <a:t> A Conversation with Erich Gamma, Part III, Bill Venners, Artima, 2005, https://www.artima.com/articles/design-principles-from-design-patterns</a:t>
             </a:r>
           </a:p>
           <a:p>
@@ -3424,27 +3434,37 @@
                 <a:latin typeface="맑은 고딕"/>
                 <a:ea typeface="맑은 고딕"/>
               </a:rPr>
-              <a:t>[Gamma 2005]</a:t>
-            </a:r>
-            <a:r>
-              <a:rPr sz="800" b="0">
-                <a:solidFill>
-                  <a:srgbClr val="000000"/>
-                </a:solidFill>
-                <a:latin typeface="맑은 고딕"/>
-                <a:ea typeface="맑은 고딕"/>
-              </a:rPr>
-              <a:t>  Design Principles from Design Patterns —</a:t>
-            </a:r>
-            <a:r>
-              <a:rPr sz="800" b="0">
-                <a:solidFill>
-                  <a:srgbClr val="000000"/>
-                </a:solidFill>
-                <a:latin typeface="맑은 고딕"/>
-                <a:ea typeface="맑은 고딕"/>
-              </a:rPr>
-              <a:t> A Conversation with Erich Gamma, Part III, Bill Venners, Artima, 2005, https://www.artima.com/articles/design-principles-from-design-patterns</a:t>
+              <a:t>[Gruber 1993]</a:t>
+            </a:r>
+            <a:r>
+              <a:rPr sz="800" b="0">
+                <a:solidFill>
+                  <a:srgbClr val="000000"/>
+                </a:solidFill>
+                <a:latin typeface="맑은 고딕"/>
+                <a:ea typeface="맑은 고딕"/>
+              </a:rPr>
+              <a:t>  A Translation Approach to Portable Ontology Specifications, Thomas R. Gruber, Knowledge Acquisition 5</a:t>
+            </a:r>
+            <a:r>
+              <a:rPr sz="800" b="0">
+                <a:solidFill>
+                  <a:srgbClr val="000000"/>
+                </a:solidFill>
+                <a:latin typeface="맑은 고딕"/>
+                <a:ea typeface="맑은 고딕"/>
+              </a:rPr>
+              <a:t>(2)</a:t>
+            </a:r>
+            <a:r>
+              <a:rPr sz="800" b="0">
+                <a:solidFill>
+                  <a:srgbClr val="000000"/>
+                </a:solidFill>
+                <a:latin typeface="맑은 고딕"/>
+                <a:ea typeface="맑은 고딕"/>
+              </a:rPr>
+              <a:t>, 1993</a:t>
             </a:r>
           </a:p>
           <a:p>
@@ -3475,17 +3495,58 @@
                 <a:latin typeface="맑은 고딕"/>
                 <a:ea typeface="맑은 고딕"/>
               </a:rPr>
-              <a:t>[Gruber 1993]</a:t>
-            </a:r>
-            <a:r>
-              <a:rPr sz="800" b="0">
-                <a:solidFill>
-                  <a:srgbClr val="000000"/>
-                </a:solidFill>
-                <a:latin typeface="맑은 고딕"/>
-                <a:ea typeface="맑은 고딕"/>
-              </a:rPr>
-              <a:t>  A Translation Approach to Portable Ontology Specifications, Thomas R. Gruber, Knowledge Acquisition 5</a:t>
+              <a:t>[Harel 1987]</a:t>
+            </a:r>
+            <a:r>
+              <a:rPr sz="800" b="0">
+                <a:solidFill>
+                  <a:srgbClr val="000000"/>
+                </a:solidFill>
+                <a:latin typeface="맑은 고딕"/>
+                <a:ea typeface="맑은 고딕"/>
+              </a:rPr>
+              <a:t>  Statecharts: A Visual Formalism for Complex Systems, David Harel, Science of Computer Programming, 1987</a:t>
+            </a:r>
+          </a:p>
+          <a:p>
+            <a:pPr lvl="2" marL="167640" indent="-167640">
+              <a:spcBef>
+                <a:spcPts val="100"/>
+              </a:spcBef>
+              <a:spcAft>
+                <a:spcPts val="100"/>
+              </a:spcAft>
+              <a:buNone/>
+            </a:pPr>
+            <a:r>
+              <a:rPr sz="800" b="0">
+                <a:solidFill>
+                  <a:srgbClr val="000000"/>
+                </a:solidFill>
+                <a:latin typeface="맑은 고딕"/>
+                <a:ea typeface="맑은 고딕"/>
+              </a:rPr>
+              <a:t>37. </a:t>
+            </a:r>
+            <a:r>
+              <a:rPr sz="800" b="1">
+                <a:solidFill>
+                  <a:srgbClr val="000000"/>
+                </a:solidFill>
+                <a:latin typeface="맑은 고딕"/>
+                <a:ea typeface="맑은 고딕"/>
+              </a:rPr>
+              <a:t>[Hoare 1981]</a:t>
+            </a:r>
+            <a:r>
+              <a:rPr sz="800" b="0">
+                <a:solidFill>
+                  <a:srgbClr val="000000"/>
+                </a:solidFill>
+                <a:latin typeface="맑은 고딕"/>
+                <a:ea typeface="맑은 고딕"/>
+              </a:rPr>
+              <a:t>  The Emperor's Old Clothes, C. A. R. Hoare, Communications of the ACM 24</a:t>
             </a:r>
             <a:r>
               <a:rPr sz="800" b="0">
@@ -3505,7 +3566,7 @@
                 <a:latin typeface="맑은 고딕"/>
                 <a:ea typeface="맑은 고딕"/>
               </a:rPr>
-              <a:t>, 1993</a:t>
+              <a:t>, 1981</a:t>
             </a:r>
           </a:p>
           <a:p>
@@ -3526,27 +3587,27 @@
                 <a:latin typeface="맑은 고딕"/>
                 <a:ea typeface="맑은 고딕"/>
               </a:rPr>
-              <a:t>37. </a:t>
-            </a:r>
-            <a:r>
-              <a:rPr sz="800" b="1">
-                <a:solidFill>
-                  <a:srgbClr val="000000"/>
-                </a:solidFill>
-                <a:latin typeface="맑은 고딕"/>
-                <a:ea typeface="맑은 고딕"/>
-              </a:rPr>
-              <a:t>[Harel 1987]</a:t>
-            </a:r>
-            <a:r>
-              <a:rPr sz="800" b="0">
-                <a:solidFill>
-                  <a:srgbClr val="000000"/>
-                </a:solidFill>
-                <a:latin typeface="맑은 고딕"/>
-                <a:ea typeface="맑은 고딕"/>
-              </a:rPr>
-              <a:t>  Statecharts: A Visual Formalism for Complex Systems, David Harel, Science of Computer Programming, 1987</a:t>
+              <a:t>38. </a:t>
+            </a:r>
+            <a:r>
+              <a:rPr sz="800" b="1">
+                <a:solidFill>
+                  <a:srgbClr val="000000"/>
+                </a:solidFill>
+                <a:latin typeface="맑은 고딕"/>
+                <a:ea typeface="맑은 고딕"/>
+              </a:rPr>
+              <a:t>[Humble]</a:t>
+            </a:r>
+            <a:r>
+              <a:rPr sz="800" b="0">
+                <a:solidFill>
+                  <a:srgbClr val="000000"/>
+                </a:solidFill>
+                <a:latin typeface="맑은 고딕"/>
+                <a:ea typeface="맑은 고딕"/>
+              </a:rPr>
+              <a:t>  Principles, Jez Humble, continuousdelivery.com, https://continuousdelivery.com/principles/</a:t>
             </a:r>
           </a:p>
           <a:p>
@@ -3567,47 +3628,27 @@
                 <a:latin typeface="맑은 고딕"/>
                 <a:ea typeface="맑은 고딕"/>
               </a:rPr>
-              <a:t>38. </a:t>
-            </a:r>
-            <a:r>
-              <a:rPr sz="800" b="1">
-                <a:solidFill>
-                  <a:srgbClr val="000000"/>
-                </a:solidFill>
-                <a:latin typeface="맑은 고딕"/>
-                <a:ea typeface="맑은 고딕"/>
-              </a:rPr>
-              <a:t>[Hoare 1981]</a:t>
-            </a:r>
-            <a:r>
-              <a:rPr sz="800" b="0">
-                <a:solidFill>
-                  <a:srgbClr val="000000"/>
-                </a:solidFill>
-                <a:latin typeface="맑은 고딕"/>
-                <a:ea typeface="맑은 고딕"/>
-              </a:rPr>
-              <a:t>  The Emperor's Old Clothes, C. A. R. Hoare, Communications of the ACM 24</a:t>
-            </a:r>
-            <a:r>
-              <a:rPr sz="800" b="0">
-                <a:solidFill>
-                  <a:srgbClr val="000000"/>
-                </a:solidFill>
-                <a:latin typeface="맑은 고딕"/>
-                <a:ea typeface="맑은 고딕"/>
-              </a:rPr>
-              <a:t>(2)</a:t>
-            </a:r>
-            <a:r>
-              <a:rPr sz="800" b="0">
-                <a:solidFill>
-                  <a:srgbClr val="000000"/>
-                </a:solidFill>
-                <a:latin typeface="맑은 고딕"/>
-                <a:ea typeface="맑은 고딕"/>
-              </a:rPr>
-              <a:t>, 1981</a:t>
+              <a:t>39. </a:t>
+            </a:r>
+            <a:r>
+              <a:rPr sz="800" b="1">
+                <a:solidFill>
+                  <a:srgbClr val="000000"/>
+                </a:solidFill>
+                <a:latin typeface="맑은 고딕"/>
+                <a:ea typeface="맑은 고딕"/>
+              </a:rPr>
+              <a:t>[IIBA 2017]</a:t>
+            </a:r>
+            <a:r>
+              <a:rPr sz="800" b="0">
+                <a:solidFill>
+                  <a:srgbClr val="000000"/>
+                </a:solidFill>
+                <a:latin typeface="맑은 고딕"/>
+                <a:ea typeface="맑은 고딕"/>
+              </a:rPr>
+              <a:t>  Global Business Analysis Core Standard, International Institute of Business Analysis, 2017, https://www.iiba.org/globalassets/standards-and-resources/core-standard/iiba-core-standard.pdf</a:t>
             </a:r>
           </a:p>
           <a:p>
@@ -3628,27 +3669,27 @@
                 <a:latin typeface="맑은 고딕"/>
                 <a:ea typeface="맑은 고딕"/>
               </a:rPr>
-              <a:t>39. </a:t>
-            </a:r>
-            <a:r>
-              <a:rPr sz="800" b="1">
-                <a:solidFill>
-                  <a:srgbClr val="000000"/>
-                </a:solidFill>
-                <a:latin typeface="맑은 고딕"/>
-                <a:ea typeface="맑은 고딕"/>
-              </a:rPr>
-              <a:t>[Humble]</a:t>
-            </a:r>
-            <a:r>
-              <a:rPr sz="800" b="0">
-                <a:solidFill>
-                  <a:srgbClr val="000000"/>
-                </a:solidFill>
-                <a:latin typeface="맑은 고딕"/>
-                <a:ea typeface="맑은 고딕"/>
-              </a:rPr>
-              <a:t>  Principles, Jez Humble, continuousdelivery.com, https://continuousdelivery.com/principles/</a:t>
+              <a:t>40. </a:t>
+            </a:r>
+            <a:r>
+              <a:rPr sz="800" b="1">
+                <a:solidFill>
+                  <a:srgbClr val="000000"/>
+                </a:solidFill>
+                <a:latin typeface="맑은 고딕"/>
+                <a:ea typeface="맑은 고딕"/>
+              </a:rPr>
+              <a:t>[IIBA 2022]</a:t>
+            </a:r>
+            <a:r>
+              <a:rPr sz="800" b="0">
+                <a:solidFill>
+                  <a:srgbClr val="000000"/>
+                </a:solidFill>
+                <a:latin typeface="맑은 고딕"/>
+                <a:ea typeface="맑은 고딕"/>
+              </a:rPr>
+              <a:t>  The Business Analysis Standard, IIBA, 2022</a:t>
             </a:r>
           </a:p>
           <a:p>
@@ -3669,47 +3710,6 @@
                 <a:latin typeface="맑은 고딕"/>
                 <a:ea typeface="맑은 고딕"/>
               </a:rPr>
-              <a:t>40. </a:t>
-            </a:r>
-            <a:r>
-              <a:rPr sz="800" b="1">
-                <a:solidFill>
-                  <a:srgbClr val="000000"/>
-                </a:solidFill>
-                <a:latin typeface="맑은 고딕"/>
-                <a:ea typeface="맑은 고딕"/>
-              </a:rPr>
-              <a:t>[IIBA 2022]</a:t>
-            </a:r>
-            <a:r>
-              <a:rPr sz="800" b="0">
-                <a:solidFill>
-                  <a:srgbClr val="000000"/>
-                </a:solidFill>
-                <a:latin typeface="맑은 고딕"/>
-                <a:ea typeface="맑은 고딕"/>
-              </a:rPr>
-              <a:t>  The Business Analysis Standard, IIBA, 2022</a:t>
-            </a:r>
-          </a:p>
-          <a:p>
-            <a:pPr lvl="2" marL="167640" indent="-167640">
-              <a:spcBef>
-                <a:spcPts val="100"/>
-              </a:spcBef>
-              <a:spcAft>
-                <a:spcPts val="100"/>
-              </a:spcAft>
-              <a:buNone/>
-            </a:pPr>
-            <a:r>
-              <a:rPr sz="800" b="0">
-                <a:solidFill>
-                  <a:srgbClr val="000000"/>
-                </a:solidFill>
-                <a:latin typeface="맑은 고딕"/>
-                <a:ea typeface="맑은 고딕"/>
-              </a:rPr>
               <a:t>41. </a:t>
             </a:r>
             <a:r>
@@ -3731,47 +3731,6 @@
                 <a:ea typeface="맑은 고딕"/>
               </a:rPr>
               <a:t>  Object-Oriented Software Engineering: A Use Case Driven Approach, Ivar Jacobson 외, Addison-Wesley, 1992</a:t>
-            </a:r>
-          </a:p>
-          <a:p>
-            <a:pPr lvl="2" marL="167640" indent="-167640">
-              <a:spcBef>
-                <a:spcPts val="100"/>
-              </a:spcBef>
-              <a:spcAft>
-                <a:spcPts val="100"/>
-              </a:spcAft>
-              <a:buNone/>
-            </a:pPr>
-            <a:r>
-              <a:rPr sz="800" b="0">
-                <a:solidFill>
-                  <a:srgbClr val="000000"/>
-                </a:solidFill>
-                <a:latin typeface="맑은 고딕"/>
-                <a:ea typeface="맑은 고딕"/>
-              </a:rPr>
-              <a:t>42. </a:t>
-            </a:r>
-            <a:r>
-              <a:rPr sz="800" b="1">
-                <a:solidFill>
-                  <a:srgbClr val="000000"/>
-                </a:solidFill>
-                <a:latin typeface="맑은 고딕"/>
-                <a:ea typeface="맑은 고딕"/>
-              </a:rPr>
-              <a:t>[Jeffries 2001]</a:t>
-            </a:r>
-            <a:r>
-              <a:rPr sz="800" b="0">
-                <a:solidFill>
-                  <a:srgbClr val="000000"/>
-                </a:solidFill>
-                <a:latin typeface="맑은 고딕"/>
-                <a:ea typeface="맑은 고딕"/>
-              </a:rPr>
-              <a:t>  Essential XP: Card, Conversation, Confirmation, Ron Jeffries, 2001</a:t>
             </a:r>
           </a:p>
         </p:txBody>
@@ -4014,6 +3973,47 @@
                 <a:latin typeface="맑은 고딕"/>
                 <a:ea typeface="맑은 고딕"/>
               </a:rPr>
+              <a:t>42. </a:t>
+            </a:r>
+            <a:r>
+              <a:rPr sz="800" b="1">
+                <a:solidFill>
+                  <a:srgbClr val="000000"/>
+                </a:solidFill>
+                <a:latin typeface="맑은 고딕"/>
+                <a:ea typeface="맑은 고딕"/>
+              </a:rPr>
+              <a:t>[Jeffries 2001]</a:t>
+            </a:r>
+            <a:r>
+              <a:rPr sz="800" b="0">
+                <a:solidFill>
+                  <a:srgbClr val="000000"/>
+                </a:solidFill>
+                <a:latin typeface="맑은 고딕"/>
+                <a:ea typeface="맑은 고딕"/>
+              </a:rPr>
+              <a:t>  Essential XP: Card, Conversation, Confirmation, Ron Jeffries, 2001</a:t>
+            </a:r>
+          </a:p>
+          <a:p>
+            <a:pPr lvl="2" marL="167640" indent="-167640">
+              <a:spcBef>
+                <a:spcPts val="100"/>
+              </a:spcBef>
+              <a:spcAft>
+                <a:spcPts val="100"/>
+              </a:spcAft>
+              <a:buNone/>
+            </a:pPr>
+            <a:r>
+              <a:rPr sz="800" b="0">
+                <a:solidFill>
+                  <a:srgbClr val="000000"/>
+                </a:solidFill>
+                <a:latin typeface="맑은 고딕"/>
+                <a:ea typeface="맑은 고딕"/>
+              </a:rPr>
               <a:t>43. </a:t>
             </a:r>
             <a:r>
@@ -4034,7 +4034,7 @@
                 <a:latin typeface="맑은 고딕"/>
                 <a:ea typeface="맑은 고딕"/>
               </a:rPr>
-              <a:t>  XP 2002 기조 발표, Jim Johnson</a:t>
+              <a:t>  XP 2002 발표, Jim Johnson</a:t>
             </a:r>
             <a:r>
               <a:rPr sz="800" b="0">

</xml_diff>